<commit_message>
Updated my pitch deck
</commit_message>
<xml_diff>
--- a/candidate_2/slides/pitch_deck.pptx
+++ b/candidate_2/slides/pitch_deck.pptx
@@ -5,7 +5,7 @@
     <p:sldMasterId id="2147483648" r:id="rId1"/>
   </p:sldMasterIdLst>
   <p:notesMasterIdLst>
-    <p:notesMasterId r:id="rId9"/>
+    <p:notesMasterId r:id="rId10"/>
   </p:notesMasterIdLst>
   <p:sldIdLst>
     <p:sldId id="263" r:id="rId2"/>
@@ -14,7 +14,8 @@
     <p:sldId id="265" r:id="rId5"/>
     <p:sldId id="266" r:id="rId6"/>
     <p:sldId id="267" r:id="rId7"/>
-    <p:sldId id="268" r:id="rId8"/>
+    <p:sldId id="270" r:id="rId8"/>
+    <p:sldId id="268" r:id="rId9"/>
   </p:sldIdLst>
   <p:sldSz cx="12192000" cy="6858000"/>
   <p:notesSz cx="6858000" cy="12192000"/>
@@ -813,6 +814,90 @@
             <a:fld id="{F7021451-1387-4CA6-816F-3879F97B5CBC}" type="slidenum">
               <a:rPr lang="en-US"/>
               <a:t>7</a:t>
+            </a:fld>
+            <a:endParaRPr lang="en-US"/>
+          </a:p>
+        </p:txBody>
+      </p:sp>
+    </p:spTree>
+    <p:extLst>
+      <p:ext uri="{BB962C8B-B14F-4D97-AF65-F5344CB8AC3E}">
+        <p14:creationId xmlns:p14="http://schemas.microsoft.com/office/powerpoint/2010/main" val="388338333"/>
+      </p:ext>
+    </p:extLst>
+  </p:cSld>
+  <p:clrMapOvr>
+    <a:masterClrMapping/>
+  </p:clrMapOvr>
+</p:notes>
+</file>
+
+<file path=ppt/notesSlides/notesSlide8.xml><?xml version="1.0" encoding="utf-8"?>
+<p:notes xmlns:a="http://schemas.openxmlformats.org/drawingml/2006/main" xmlns:r="http://schemas.openxmlformats.org/officeDocument/2006/relationships" xmlns:p="http://schemas.openxmlformats.org/presentationml/2006/main">
+  <p:cSld>
+    <p:spTree>
+      <p:nvGrpSpPr>
+        <p:cNvPr id="1" name=""/>
+        <p:cNvGrpSpPr/>
+        <p:nvPr/>
+      </p:nvGrpSpPr>
+      <p:grpSpPr>
+        <a:xfrm>
+          <a:off x="0" y="0"/>
+          <a:ext cx="0" cy="0"/>
+          <a:chOff x="0" y="0"/>
+          <a:chExt cx="0" cy="0"/>
+        </a:xfrm>
+      </p:grpSpPr>
+      <p:sp>
+        <p:nvSpPr>
+          <p:cNvPr id="2" name="Slide Image Placeholder 1"/>
+          <p:cNvSpPr>
+            <a:spLocks noGrp="1" noRot="1" noChangeAspect="1"/>
+          </p:cNvSpPr>
+          <p:nvPr>
+            <p:ph type="sldImg"/>
+          </p:nvPr>
+        </p:nvSpPr>
+        <p:spPr/>
+      </p:sp>
+      <p:sp>
+        <p:nvSpPr>
+          <p:cNvPr id="3" name="Notes Placeholder 2"/>
+          <p:cNvSpPr>
+            <a:spLocks noGrp="1"/>
+          </p:cNvSpPr>
+          <p:nvPr>
+            <p:ph type="body" idx="1"/>
+          </p:nvPr>
+        </p:nvSpPr>
+        <p:spPr/>
+        <p:txBody>
+          <a:bodyPr/>
+          <a:lstStyle/>
+          <a:p>
+            <a:endParaRPr lang="en-US" dirty="0"/>
+          </a:p>
+        </p:txBody>
+      </p:sp>
+      <p:sp>
+        <p:nvSpPr>
+          <p:cNvPr id="4" name="Slide Number Placeholder 3"/>
+          <p:cNvSpPr>
+            <a:spLocks noGrp="1"/>
+          </p:cNvSpPr>
+          <p:nvPr>
+            <p:ph type="sldNum" sz="quarter" idx="10"/>
+          </p:nvPr>
+        </p:nvSpPr>
+        <p:spPr/>
+        <p:txBody>
+          <a:bodyPr/>
+          <a:lstStyle/>
+          <a:p>
+            <a:fld id="{F7021451-1387-4CA6-816F-3879F97B5CBC}" type="slidenum">
+              <a:rPr lang="en-US"/>
+              <a:t>8</a:t>
             </a:fld>
             <a:endParaRPr lang="en-US"/>
           </a:p>
@@ -1207,7 +1292,29 @@
                 <a:ea typeface="Calibri" pitchFamily="34" charset="-122"/>
                 <a:cs typeface="Calibri" pitchFamily="34" charset="-120"/>
               </a:rPr>
-              <a:t>Questions this pitch deck attempts to answer…</a:t>
+              <a:t>Questions </a:t>
+            </a:r>
+            <a:r>
+              <a:rPr lang="en-US" sz="4000" b="1">
+                <a:solidFill>
+                  <a:srgbClr val="F8FAFC"/>
+                </a:solidFill>
+                <a:latin typeface="Calibri" pitchFamily="34" charset="0"/>
+                <a:ea typeface="Calibri" pitchFamily="34" charset="-122"/>
+                <a:cs typeface="Calibri" pitchFamily="34" charset="-120"/>
+              </a:rPr>
+              <a:t>these slides </a:t>
+            </a:r>
+            <a:r>
+              <a:rPr lang="en-US" sz="4000" b="1" dirty="0">
+                <a:solidFill>
+                  <a:srgbClr val="F8FAFC"/>
+                </a:solidFill>
+                <a:latin typeface="Calibri" pitchFamily="34" charset="0"/>
+                <a:ea typeface="Calibri" pitchFamily="34" charset="-122"/>
+                <a:cs typeface="Calibri" pitchFamily="34" charset="-120"/>
+              </a:rPr>
+              <a:t>attempts to answer…</a:t>
             </a:r>
             <a:endParaRPr lang="en-US" sz="4000" dirty="0"/>
           </a:p>
@@ -2433,6 +2540,802 @@
         </p:nvSpPr>
         <p:spPr>
           <a:xfrm>
+            <a:off x="621036" y="269855"/>
+            <a:ext cx="10949624" cy="479085"/>
+          </a:xfrm>
+          <a:prstGeom prst="rect">
+            <a:avLst/>
+          </a:prstGeom>
+          <a:noFill/>
+          <a:ln/>
+        </p:spPr>
+        <p:txBody>
+          <a:bodyPr wrap="square" lIns="0" tIns="0" rIns="0" bIns="0" rtlCol="0" anchor="t"/>
+          <a:lstStyle/>
+          <a:p>
+            <a:pPr marL="0" indent="0">
+              <a:buNone/>
+            </a:pPr>
+            <a:r>
+              <a:rPr lang="en-US" sz="2000" b="1" dirty="0">
+                <a:solidFill>
+                  <a:schemeClr val="bg2"/>
+                </a:solidFill>
+                <a:latin typeface="Cascadia Code" panose="020B0609020000020004" pitchFamily="49" charset="0"/>
+                <a:ea typeface="Cascadia Code" panose="020B0609020000020004" pitchFamily="49" charset="0"/>
+                <a:cs typeface="Cascadia Code" panose="020B0609020000020004" pitchFamily="49" charset="0"/>
+              </a:rPr>
+              <a:t>Benchmarks…</a:t>
+            </a:r>
+          </a:p>
+        </p:txBody>
+      </p:sp>
+      <p:sp>
+        <p:nvSpPr>
+          <p:cNvPr id="6" name="TextBox 5">
+            <a:extLst>
+              <a:ext uri="{FF2B5EF4-FFF2-40B4-BE49-F238E27FC236}">
+                <a16:creationId xmlns:a16="http://schemas.microsoft.com/office/drawing/2014/main" id="{317B8A77-0934-47FF-9014-0AD419BDBA05}"/>
+              </a:ext>
+            </a:extLst>
+          </p:cNvPr>
+          <p:cNvSpPr txBox="1"/>
+          <p:nvPr/>
+        </p:nvSpPr>
+        <p:spPr>
+          <a:xfrm>
+            <a:off x="7273284" y="4285453"/>
+            <a:ext cx="3230881" cy="923330"/>
+          </a:xfrm>
+          <a:prstGeom prst="rect">
+            <a:avLst/>
+          </a:prstGeom>
+          <a:noFill/>
+        </p:spPr>
+        <p:txBody>
+          <a:bodyPr wrap="square" rtlCol="0">
+            <a:spAutoFit/>
+          </a:bodyPr>
+          <a:lstStyle/>
+          <a:p>
+            <a:r>
+              <a:rPr lang="en-US" dirty="0">
+                <a:solidFill>
+                  <a:schemeClr val="bg2"/>
+                </a:solidFill>
+                <a:latin typeface="Cascadia Code" panose="020B0609020000020004" pitchFamily="49" charset="0"/>
+                <a:ea typeface="Cascadia Code" panose="020B0609020000020004" pitchFamily="49" charset="0"/>
+                <a:cs typeface="Cascadia Code" panose="020B0609020000020004" pitchFamily="49" charset="0"/>
+              </a:rPr>
+              <a:t>After 5 runs, Polars completed aggregation 5.52x faster.</a:t>
+            </a:r>
+            <a:endParaRPr lang="en-NG" dirty="0">
+              <a:solidFill>
+                <a:schemeClr val="bg2"/>
+              </a:solidFill>
+              <a:latin typeface="Cascadia Code" panose="020B0609020000020004" pitchFamily="49" charset="0"/>
+              <a:ea typeface="Cascadia Code" panose="020B0609020000020004" pitchFamily="49" charset="0"/>
+              <a:cs typeface="Cascadia Code" panose="020B0609020000020004" pitchFamily="49" charset="0"/>
+            </a:endParaRPr>
+          </a:p>
+        </p:txBody>
+      </p:sp>
+      <p:graphicFrame>
+        <p:nvGraphicFramePr>
+          <p:cNvPr id="2" name="Table 3">
+            <a:extLst>
+              <a:ext uri="{FF2B5EF4-FFF2-40B4-BE49-F238E27FC236}">
+                <a16:creationId xmlns:a16="http://schemas.microsoft.com/office/drawing/2014/main" id="{1DAC8DB7-9594-4E6A-B692-A293641FDECA}"/>
+              </a:ext>
+            </a:extLst>
+          </p:cNvPr>
+          <p:cNvGraphicFramePr>
+            <a:graphicFrameLocks noGrp="1"/>
+          </p:cNvGraphicFramePr>
+          <p:nvPr>
+            <p:extLst>
+              <p:ext uri="{D42A27DB-BD31-4B8C-83A1-F6EECF244321}">
+                <p14:modId xmlns:p14="http://schemas.microsoft.com/office/powerpoint/2010/main" val="1896254321"/>
+              </p:ext>
+            </p:extLst>
+          </p:nvPr>
+        </p:nvGraphicFramePr>
+        <p:xfrm>
+          <a:off x="720084" y="1854926"/>
+          <a:ext cx="3892731" cy="1976844"/>
+        </p:xfrm>
+        <a:graphic>
+          <a:graphicData uri="http://schemas.openxmlformats.org/drawingml/2006/table">
+            <a:tbl>
+              <a:tblPr firstRow="1" bandRow="1">
+                <a:tableStyleId>{7E9639D4-E3E2-4D34-9284-5A2195B3D0D7}</a:tableStyleId>
+              </a:tblPr>
+              <a:tblGrid>
+                <a:gridCol w="1297577">
+                  <a:extLst>
+                    <a:ext uri="{9D8B030D-6E8A-4147-A177-3AD203B41FA5}">
+                      <a16:colId xmlns:a16="http://schemas.microsoft.com/office/drawing/2014/main" val="211208285"/>
+                    </a:ext>
+                  </a:extLst>
+                </a:gridCol>
+                <a:gridCol w="1297577">
+                  <a:extLst>
+                    <a:ext uri="{9D8B030D-6E8A-4147-A177-3AD203B41FA5}">
+                      <a16:colId xmlns:a16="http://schemas.microsoft.com/office/drawing/2014/main" val="2932182459"/>
+                    </a:ext>
+                  </a:extLst>
+                </a:gridCol>
+                <a:gridCol w="1297577">
+                  <a:extLst>
+                    <a:ext uri="{9D8B030D-6E8A-4147-A177-3AD203B41FA5}">
+                      <a16:colId xmlns:a16="http://schemas.microsoft.com/office/drawing/2014/main" val="118212405"/>
+                    </a:ext>
+                  </a:extLst>
+                </a:gridCol>
+              </a:tblGrid>
+              <a:tr h="658948">
+                <a:tc>
+                  <a:txBody>
+                    <a:bodyPr/>
+                    <a:lstStyle/>
+                    <a:p>
+                      <a:r>
+                        <a:rPr lang="en-US" dirty="0">
+                          <a:latin typeface="+mn-lt"/>
+                        </a:rPr>
+                        <a:t>Tool</a:t>
+                      </a:r>
+                      <a:endParaRPr lang="en-NG" dirty="0">
+                        <a:latin typeface="+mn-lt"/>
+                      </a:endParaRPr>
+                    </a:p>
+                  </a:txBody>
+                  <a:tcPr>
+                    <a:solidFill>
+                      <a:schemeClr val="accent1">
+                        <a:lumMod val="75000"/>
+                      </a:schemeClr>
+                    </a:solidFill>
+                  </a:tcPr>
+                </a:tc>
+                <a:tc>
+                  <a:txBody>
+                    <a:bodyPr/>
+                    <a:lstStyle/>
+                    <a:p>
+                      <a:r>
+                        <a:rPr lang="en-US" dirty="0">
+                          <a:latin typeface="+mn-lt"/>
+                        </a:rPr>
+                        <a:t>Read Time</a:t>
+                      </a:r>
+                      <a:endParaRPr lang="en-NG" dirty="0">
+                        <a:latin typeface="+mn-lt"/>
+                      </a:endParaRPr>
+                    </a:p>
+                  </a:txBody>
+                  <a:tcPr>
+                    <a:solidFill>
+                      <a:schemeClr val="accent1">
+                        <a:lumMod val="75000"/>
+                      </a:schemeClr>
+                    </a:solidFill>
+                  </a:tcPr>
+                </a:tc>
+                <a:tc>
+                  <a:txBody>
+                    <a:bodyPr/>
+                    <a:lstStyle/>
+                    <a:p>
+                      <a:r>
+                        <a:rPr lang="en-US" dirty="0">
+                          <a:latin typeface="+mn-lt"/>
+                        </a:rPr>
+                        <a:t>Peak Memory</a:t>
+                      </a:r>
+                      <a:endParaRPr lang="en-NG" dirty="0">
+                        <a:latin typeface="+mn-lt"/>
+                      </a:endParaRPr>
+                    </a:p>
+                  </a:txBody>
+                  <a:tcPr>
+                    <a:solidFill>
+                      <a:schemeClr val="accent1">
+                        <a:lumMod val="75000"/>
+                      </a:schemeClr>
+                    </a:solidFill>
+                  </a:tcPr>
+                </a:tc>
+                <a:extLst>
+                  <a:ext uri="{0D108BD9-81ED-4DB2-BD59-A6C34878D82A}">
+                    <a16:rowId xmlns:a16="http://schemas.microsoft.com/office/drawing/2014/main" val="1829001214"/>
+                  </a:ext>
+                </a:extLst>
+              </a:tr>
+              <a:tr h="658948">
+                <a:tc>
+                  <a:txBody>
+                    <a:bodyPr/>
+                    <a:lstStyle/>
+                    <a:p>
+                      <a:r>
+                        <a:rPr lang="en-US" sz="1500" dirty="0">
+                          <a:solidFill>
+                            <a:schemeClr val="bg1"/>
+                          </a:solidFill>
+                        </a:rPr>
+                        <a:t>Pandas</a:t>
+                      </a:r>
+                      <a:endParaRPr lang="en-NG" sz="1500" dirty="0">
+                        <a:solidFill>
+                          <a:schemeClr val="bg1"/>
+                        </a:solidFill>
+                      </a:endParaRPr>
+                    </a:p>
+                  </a:txBody>
+                  <a:tcPr/>
+                </a:tc>
+                <a:tc>
+                  <a:txBody>
+                    <a:bodyPr/>
+                    <a:lstStyle/>
+                    <a:p>
+                      <a:r>
+                        <a:rPr lang="en-US" sz="1500" dirty="0">
+                          <a:solidFill>
+                            <a:schemeClr val="bg1"/>
+                          </a:solidFill>
+                        </a:rPr>
+                        <a:t>311.76 ms</a:t>
+                      </a:r>
+                      <a:endParaRPr lang="en-NG" sz="1500" dirty="0">
+                        <a:solidFill>
+                          <a:schemeClr val="bg1"/>
+                        </a:solidFill>
+                      </a:endParaRPr>
+                    </a:p>
+                  </a:txBody>
+                  <a:tcPr/>
+                </a:tc>
+                <a:tc>
+                  <a:txBody>
+                    <a:bodyPr/>
+                    <a:lstStyle/>
+                    <a:p>
+                      <a:r>
+                        <a:rPr lang="en-US" sz="1500" dirty="0">
+                          <a:solidFill>
+                            <a:schemeClr val="bg1"/>
+                          </a:solidFill>
+                        </a:rPr>
+                        <a:t>19.92 MB</a:t>
+                      </a:r>
+                      <a:endParaRPr lang="en-NG" sz="1500" dirty="0">
+                        <a:solidFill>
+                          <a:schemeClr val="bg1"/>
+                        </a:solidFill>
+                      </a:endParaRPr>
+                    </a:p>
+                  </a:txBody>
+                  <a:tcPr/>
+                </a:tc>
+                <a:extLst>
+                  <a:ext uri="{0D108BD9-81ED-4DB2-BD59-A6C34878D82A}">
+                    <a16:rowId xmlns:a16="http://schemas.microsoft.com/office/drawing/2014/main" val="1052372554"/>
+                  </a:ext>
+                </a:extLst>
+              </a:tr>
+              <a:tr h="658948">
+                <a:tc>
+                  <a:txBody>
+                    <a:bodyPr/>
+                    <a:lstStyle/>
+                    <a:p>
+                      <a:r>
+                        <a:rPr lang="en-US" sz="1500" dirty="0">
+                          <a:solidFill>
+                            <a:schemeClr val="bg1"/>
+                          </a:solidFill>
+                        </a:rPr>
+                        <a:t>Polars</a:t>
+                      </a:r>
+                      <a:endParaRPr lang="en-NG" sz="1500" dirty="0">
+                        <a:solidFill>
+                          <a:schemeClr val="bg1"/>
+                        </a:solidFill>
+                      </a:endParaRPr>
+                    </a:p>
+                  </a:txBody>
+                  <a:tcPr/>
+                </a:tc>
+                <a:tc>
+                  <a:txBody>
+                    <a:bodyPr/>
+                    <a:lstStyle/>
+                    <a:p>
+                      <a:r>
+                        <a:rPr lang="en-US" sz="1500" dirty="0">
+                          <a:solidFill>
+                            <a:schemeClr val="bg1"/>
+                          </a:solidFill>
+                        </a:rPr>
+                        <a:t>181.68 ms</a:t>
+                      </a:r>
+                      <a:endParaRPr lang="en-NG" sz="1500" dirty="0">
+                        <a:solidFill>
+                          <a:schemeClr val="bg1"/>
+                        </a:solidFill>
+                      </a:endParaRPr>
+                    </a:p>
+                  </a:txBody>
+                  <a:tcPr/>
+                </a:tc>
+                <a:tc>
+                  <a:txBody>
+                    <a:bodyPr/>
+                    <a:lstStyle/>
+                    <a:p>
+                      <a:r>
+                        <a:rPr lang="en-US" sz="1500" dirty="0">
+                          <a:solidFill>
+                            <a:schemeClr val="bg1"/>
+                          </a:solidFill>
+                        </a:rPr>
+                        <a:t>0.00 MB</a:t>
+                      </a:r>
+                      <a:endParaRPr lang="en-NG" sz="1500" dirty="0">
+                        <a:solidFill>
+                          <a:schemeClr val="bg1"/>
+                        </a:solidFill>
+                      </a:endParaRPr>
+                    </a:p>
+                  </a:txBody>
+                  <a:tcPr/>
+                </a:tc>
+                <a:extLst>
+                  <a:ext uri="{0D108BD9-81ED-4DB2-BD59-A6C34878D82A}">
+                    <a16:rowId xmlns:a16="http://schemas.microsoft.com/office/drawing/2014/main" val="4067028979"/>
+                  </a:ext>
+                </a:extLst>
+              </a:tr>
+            </a:tbl>
+          </a:graphicData>
+        </a:graphic>
+      </p:graphicFrame>
+      <p:sp>
+        <p:nvSpPr>
+          <p:cNvPr id="4" name="TextBox 3">
+            <a:extLst>
+              <a:ext uri="{FF2B5EF4-FFF2-40B4-BE49-F238E27FC236}">
+                <a16:creationId xmlns:a16="http://schemas.microsoft.com/office/drawing/2014/main" id="{5172F1A4-91C6-45A1-9DB5-622CB28411DC}"/>
+              </a:ext>
+            </a:extLst>
+          </p:cNvPr>
+          <p:cNvSpPr txBox="1"/>
+          <p:nvPr/>
+        </p:nvSpPr>
+        <p:spPr>
+          <a:xfrm>
+            <a:off x="3802917" y="1049328"/>
+            <a:ext cx="3361510" cy="369332"/>
+          </a:xfrm>
+          <a:prstGeom prst="rect">
+            <a:avLst/>
+          </a:prstGeom>
+          <a:noFill/>
+        </p:spPr>
+        <p:txBody>
+          <a:bodyPr wrap="square" rtlCol="0">
+            <a:spAutoFit/>
+          </a:bodyPr>
+          <a:lstStyle/>
+          <a:p>
+            <a:r>
+              <a:rPr lang="en-US" dirty="0">
+                <a:solidFill>
+                  <a:schemeClr val="bg1"/>
+                </a:solidFill>
+                <a:latin typeface="Cascadia Code" panose="020B0609020000020004" pitchFamily="49" charset="0"/>
+                <a:ea typeface="Cascadia Code" panose="020B0609020000020004" pitchFamily="49" charset="0"/>
+                <a:cs typeface="Cascadia Code" panose="020B0609020000020004" pitchFamily="49" charset="0"/>
+              </a:rPr>
+              <a:t>Dataset Rows: 1,040,200</a:t>
+            </a:r>
+            <a:endParaRPr lang="en-NG" dirty="0">
+              <a:solidFill>
+                <a:schemeClr val="bg1"/>
+              </a:solidFill>
+              <a:latin typeface="Cascadia Code" panose="020B0609020000020004" pitchFamily="49" charset="0"/>
+              <a:ea typeface="Cascadia Code" panose="020B0609020000020004" pitchFamily="49" charset="0"/>
+              <a:cs typeface="Cascadia Code" panose="020B0609020000020004" pitchFamily="49" charset="0"/>
+            </a:endParaRPr>
+          </a:p>
+        </p:txBody>
+      </p:sp>
+      <p:graphicFrame>
+        <p:nvGraphicFramePr>
+          <p:cNvPr id="8" name="Table 3">
+            <a:extLst>
+              <a:ext uri="{FF2B5EF4-FFF2-40B4-BE49-F238E27FC236}">
+                <a16:creationId xmlns:a16="http://schemas.microsoft.com/office/drawing/2014/main" id="{B89C0774-EFC0-4B85-9AB8-2D87450B82E2}"/>
+              </a:ext>
+            </a:extLst>
+          </p:cNvPr>
+          <p:cNvGraphicFramePr>
+            <a:graphicFrameLocks noGrp="1"/>
+          </p:cNvGraphicFramePr>
+          <p:nvPr>
+            <p:extLst>
+              <p:ext uri="{D42A27DB-BD31-4B8C-83A1-F6EECF244321}">
+                <p14:modId xmlns:p14="http://schemas.microsoft.com/office/powerpoint/2010/main" val="3495382687"/>
+              </p:ext>
+            </p:extLst>
+          </p:nvPr>
+        </p:nvGraphicFramePr>
+        <p:xfrm>
+          <a:off x="7273284" y="1854926"/>
+          <a:ext cx="3892731" cy="1976844"/>
+        </p:xfrm>
+        <a:graphic>
+          <a:graphicData uri="http://schemas.openxmlformats.org/drawingml/2006/table">
+            <a:tbl>
+              <a:tblPr firstRow="1" bandRow="1">
+                <a:tableStyleId>{7E9639D4-E3E2-4D34-9284-5A2195B3D0D7}</a:tableStyleId>
+              </a:tblPr>
+              <a:tblGrid>
+                <a:gridCol w="1297577">
+                  <a:extLst>
+                    <a:ext uri="{9D8B030D-6E8A-4147-A177-3AD203B41FA5}">
+                      <a16:colId xmlns:a16="http://schemas.microsoft.com/office/drawing/2014/main" val="211208285"/>
+                    </a:ext>
+                  </a:extLst>
+                </a:gridCol>
+                <a:gridCol w="1297577">
+                  <a:extLst>
+                    <a:ext uri="{9D8B030D-6E8A-4147-A177-3AD203B41FA5}">
+                      <a16:colId xmlns:a16="http://schemas.microsoft.com/office/drawing/2014/main" val="2932182459"/>
+                    </a:ext>
+                  </a:extLst>
+                </a:gridCol>
+                <a:gridCol w="1297577">
+                  <a:extLst>
+                    <a:ext uri="{9D8B030D-6E8A-4147-A177-3AD203B41FA5}">
+                      <a16:colId xmlns:a16="http://schemas.microsoft.com/office/drawing/2014/main" val="118212405"/>
+                    </a:ext>
+                  </a:extLst>
+                </a:gridCol>
+              </a:tblGrid>
+              <a:tr h="658948">
+                <a:tc>
+                  <a:txBody>
+                    <a:bodyPr/>
+                    <a:lstStyle/>
+                    <a:p>
+                      <a:r>
+                        <a:rPr lang="en-US" dirty="0">
+                          <a:latin typeface="+mn-lt"/>
+                        </a:rPr>
+                        <a:t>Tool</a:t>
+                      </a:r>
+                      <a:endParaRPr lang="en-NG" dirty="0">
+                        <a:latin typeface="+mn-lt"/>
+                      </a:endParaRPr>
+                    </a:p>
+                  </a:txBody>
+                  <a:tcPr>
+                    <a:solidFill>
+                      <a:schemeClr val="accent1">
+                        <a:lumMod val="75000"/>
+                      </a:schemeClr>
+                    </a:solidFill>
+                  </a:tcPr>
+                </a:tc>
+                <a:tc>
+                  <a:txBody>
+                    <a:bodyPr/>
+                    <a:lstStyle/>
+                    <a:p>
+                      <a:r>
+                        <a:rPr lang="en-US" dirty="0">
+                          <a:latin typeface="+mn-lt"/>
+                        </a:rPr>
+                        <a:t>Exec Time</a:t>
+                      </a:r>
+                      <a:endParaRPr lang="en-NG" dirty="0">
+                        <a:latin typeface="+mn-lt"/>
+                      </a:endParaRPr>
+                    </a:p>
+                  </a:txBody>
+                  <a:tcPr>
+                    <a:solidFill>
+                      <a:schemeClr val="accent1">
+                        <a:lumMod val="75000"/>
+                      </a:schemeClr>
+                    </a:solidFill>
+                  </a:tcPr>
+                </a:tc>
+                <a:tc>
+                  <a:txBody>
+                    <a:bodyPr/>
+                    <a:lstStyle/>
+                    <a:p>
+                      <a:r>
+                        <a:rPr lang="en-US" dirty="0">
+                          <a:latin typeface="+mn-lt"/>
+                        </a:rPr>
+                        <a:t>Peak Memory</a:t>
+                      </a:r>
+                      <a:endParaRPr lang="en-NG" dirty="0">
+                        <a:latin typeface="+mn-lt"/>
+                      </a:endParaRPr>
+                    </a:p>
+                  </a:txBody>
+                  <a:tcPr>
+                    <a:solidFill>
+                      <a:schemeClr val="accent1">
+                        <a:lumMod val="75000"/>
+                      </a:schemeClr>
+                    </a:solidFill>
+                  </a:tcPr>
+                </a:tc>
+                <a:extLst>
+                  <a:ext uri="{0D108BD9-81ED-4DB2-BD59-A6C34878D82A}">
+                    <a16:rowId xmlns:a16="http://schemas.microsoft.com/office/drawing/2014/main" val="1829001214"/>
+                  </a:ext>
+                </a:extLst>
+              </a:tr>
+              <a:tr h="658948">
+                <a:tc>
+                  <a:txBody>
+                    <a:bodyPr/>
+                    <a:lstStyle/>
+                    <a:p>
+                      <a:r>
+                        <a:rPr lang="en-US" sz="1500" dirty="0">
+                          <a:solidFill>
+                            <a:schemeClr val="bg1"/>
+                          </a:solidFill>
+                        </a:rPr>
+                        <a:t>Pandas</a:t>
+                      </a:r>
+                      <a:endParaRPr lang="en-NG" sz="1500" dirty="0">
+                        <a:solidFill>
+                          <a:schemeClr val="bg1"/>
+                        </a:solidFill>
+                      </a:endParaRPr>
+                    </a:p>
+                  </a:txBody>
+                  <a:tcPr/>
+                </a:tc>
+                <a:tc>
+                  <a:txBody>
+                    <a:bodyPr/>
+                    <a:lstStyle/>
+                    <a:p>
+                      <a:r>
+                        <a:rPr lang="en-US" sz="1500" dirty="0">
+                          <a:solidFill>
+                            <a:schemeClr val="bg1"/>
+                          </a:solidFill>
+                        </a:rPr>
+                        <a:t>283.67 ms</a:t>
+                      </a:r>
+                      <a:endParaRPr lang="en-NG" sz="1500" dirty="0">
+                        <a:solidFill>
+                          <a:schemeClr val="bg1"/>
+                        </a:solidFill>
+                      </a:endParaRPr>
+                    </a:p>
+                  </a:txBody>
+                  <a:tcPr/>
+                </a:tc>
+                <a:tc>
+                  <a:txBody>
+                    <a:bodyPr/>
+                    <a:lstStyle/>
+                    <a:p>
+                      <a:r>
+                        <a:rPr lang="en-US" sz="1500" dirty="0">
+                          <a:solidFill>
+                            <a:schemeClr val="bg1"/>
+                          </a:solidFill>
+                        </a:rPr>
+                        <a:t>72.94 MB</a:t>
+                      </a:r>
+                      <a:endParaRPr lang="en-NG" sz="1500" dirty="0">
+                        <a:solidFill>
+                          <a:schemeClr val="bg1"/>
+                        </a:solidFill>
+                      </a:endParaRPr>
+                    </a:p>
+                  </a:txBody>
+                  <a:tcPr/>
+                </a:tc>
+                <a:extLst>
+                  <a:ext uri="{0D108BD9-81ED-4DB2-BD59-A6C34878D82A}">
+                    <a16:rowId xmlns:a16="http://schemas.microsoft.com/office/drawing/2014/main" val="1052372554"/>
+                  </a:ext>
+                </a:extLst>
+              </a:tr>
+              <a:tr h="658948">
+                <a:tc>
+                  <a:txBody>
+                    <a:bodyPr/>
+                    <a:lstStyle/>
+                    <a:p>
+                      <a:r>
+                        <a:rPr lang="en-US" sz="1500" dirty="0">
+                          <a:solidFill>
+                            <a:schemeClr val="bg1"/>
+                          </a:solidFill>
+                        </a:rPr>
+                        <a:t>Polars</a:t>
+                      </a:r>
+                      <a:endParaRPr lang="en-NG" sz="1500" dirty="0">
+                        <a:solidFill>
+                          <a:schemeClr val="bg1"/>
+                        </a:solidFill>
+                      </a:endParaRPr>
+                    </a:p>
+                  </a:txBody>
+                  <a:tcPr/>
+                </a:tc>
+                <a:tc>
+                  <a:txBody>
+                    <a:bodyPr/>
+                    <a:lstStyle/>
+                    <a:p>
+                      <a:r>
+                        <a:rPr lang="en-US" sz="1500" dirty="0">
+                          <a:solidFill>
+                            <a:schemeClr val="bg1"/>
+                          </a:solidFill>
+                        </a:rPr>
+                        <a:t>51.39 ms</a:t>
+                      </a:r>
+                      <a:endParaRPr lang="en-NG" sz="1500" dirty="0">
+                        <a:solidFill>
+                          <a:schemeClr val="bg1"/>
+                        </a:solidFill>
+                      </a:endParaRPr>
+                    </a:p>
+                  </a:txBody>
+                  <a:tcPr/>
+                </a:tc>
+                <a:tc>
+                  <a:txBody>
+                    <a:bodyPr/>
+                    <a:lstStyle/>
+                    <a:p>
+                      <a:r>
+                        <a:rPr lang="en-US" sz="1500" dirty="0">
+                          <a:solidFill>
+                            <a:schemeClr val="bg1"/>
+                          </a:solidFill>
+                        </a:rPr>
+                        <a:t>0.01 MB</a:t>
+                      </a:r>
+                      <a:endParaRPr lang="en-NG" sz="1500" dirty="0">
+                        <a:solidFill>
+                          <a:schemeClr val="bg1"/>
+                        </a:solidFill>
+                      </a:endParaRPr>
+                    </a:p>
+                  </a:txBody>
+                  <a:tcPr/>
+                </a:tc>
+                <a:extLst>
+                  <a:ext uri="{0D108BD9-81ED-4DB2-BD59-A6C34878D82A}">
+                    <a16:rowId xmlns:a16="http://schemas.microsoft.com/office/drawing/2014/main" val="4067028979"/>
+                  </a:ext>
+                </a:extLst>
+              </a:tr>
+            </a:tbl>
+          </a:graphicData>
+        </a:graphic>
+      </p:graphicFrame>
+      <p:sp>
+        <p:nvSpPr>
+          <p:cNvPr id="9" name="TextBox 8">
+            <a:extLst>
+              <a:ext uri="{FF2B5EF4-FFF2-40B4-BE49-F238E27FC236}">
+                <a16:creationId xmlns:a16="http://schemas.microsoft.com/office/drawing/2014/main" id="{D023E735-71DB-4D91-AA68-16FC2B3E1FFA}"/>
+              </a:ext>
+            </a:extLst>
+          </p:cNvPr>
+          <p:cNvSpPr txBox="1"/>
+          <p:nvPr/>
+        </p:nvSpPr>
+        <p:spPr>
+          <a:xfrm>
+            <a:off x="670560" y="4285453"/>
+            <a:ext cx="3230881" cy="923330"/>
+          </a:xfrm>
+          <a:prstGeom prst="rect">
+            <a:avLst/>
+          </a:prstGeom>
+          <a:noFill/>
+        </p:spPr>
+        <p:txBody>
+          <a:bodyPr wrap="square" rtlCol="0">
+            <a:spAutoFit/>
+          </a:bodyPr>
+          <a:lstStyle/>
+          <a:p>
+            <a:r>
+              <a:rPr lang="en-US" dirty="0">
+                <a:solidFill>
+                  <a:schemeClr val="bg2"/>
+                </a:solidFill>
+                <a:latin typeface="Cascadia Code" panose="020B0609020000020004" pitchFamily="49" charset="0"/>
+                <a:ea typeface="Cascadia Code" panose="020B0609020000020004" pitchFamily="49" charset="0"/>
+                <a:cs typeface="Cascadia Code" panose="020B0609020000020004" pitchFamily="49" charset="0"/>
+              </a:rPr>
+              <a:t>After 3 runs, Polars loaded the Parquet file 1.72x faster.</a:t>
+            </a:r>
+            <a:endParaRPr lang="en-NG" dirty="0">
+              <a:solidFill>
+                <a:schemeClr val="bg2"/>
+              </a:solidFill>
+              <a:latin typeface="Cascadia Code" panose="020B0609020000020004" pitchFamily="49" charset="0"/>
+              <a:ea typeface="Cascadia Code" panose="020B0609020000020004" pitchFamily="49" charset="0"/>
+              <a:cs typeface="Cascadia Code" panose="020B0609020000020004" pitchFamily="49" charset="0"/>
+            </a:endParaRPr>
+          </a:p>
+        </p:txBody>
+      </p:sp>
+    </p:spTree>
+    <p:extLst>
+      <p:ext uri="{BB962C8B-B14F-4D97-AF65-F5344CB8AC3E}">
+        <p14:creationId xmlns:p14="http://schemas.microsoft.com/office/powerpoint/2010/main" val="2100184109"/>
+      </p:ext>
+    </p:extLst>
+  </p:cSld>
+  <p:clrMapOvr>
+    <a:masterClrMapping/>
+  </p:clrMapOvr>
+</p:sld>
+</file>
+
+<file path=ppt/slides/slide8.xml><?xml version="1.0" encoding="utf-8"?>
+<p:sld xmlns:a="http://schemas.openxmlformats.org/drawingml/2006/main" xmlns:r="http://schemas.openxmlformats.org/officeDocument/2006/relationships" xmlns:p="http://schemas.openxmlformats.org/presentationml/2006/main">
+  <p:cSld>
+    <p:bg>
+      <p:bgPr>
+        <a:solidFill>
+          <a:srgbClr val="0F172A"/>
+        </a:solidFill>
+        <a:effectLst/>
+      </p:bgPr>
+    </p:bg>
+    <p:spTree>
+      <p:nvGrpSpPr>
+        <p:cNvPr id="1" name=""/>
+        <p:cNvGrpSpPr/>
+        <p:nvPr/>
+      </p:nvGrpSpPr>
+      <p:grpSpPr>
+        <a:xfrm>
+          <a:off x="0" y="0"/>
+          <a:ext cx="0" cy="0"/>
+          <a:chOff x="0" y="0"/>
+          <a:chExt cx="0" cy="0"/>
+        </a:xfrm>
+      </p:grpSpPr>
+      <p:sp>
+        <p:nvSpPr>
+          <p:cNvPr id="12" name="Text 1">
+            <a:extLst>
+              <a:ext uri="{FF2B5EF4-FFF2-40B4-BE49-F238E27FC236}">
+                <a16:creationId xmlns:a16="http://schemas.microsoft.com/office/drawing/2014/main" id="{F698D9C9-7359-449B-B860-E8C9764E34DF}"/>
+              </a:ext>
+            </a:extLst>
+          </p:cNvPr>
+          <p:cNvSpPr txBox="1"/>
+          <p:nvPr/>
+        </p:nvSpPr>
+        <p:spPr>
+          <a:xfrm>
             <a:off x="621036" y="304689"/>
             <a:ext cx="10949624" cy="479085"/>
           </a:xfrm>
@@ -2565,7 +3468,7 @@
                 <a:ea typeface="Cascadia Code" panose="020B0609020000020004" pitchFamily="49" charset="0"/>
                 <a:cs typeface="Cascadia Code" panose="020B0609020000020004" pitchFamily="49" charset="0"/>
               </a:rPr>
-              <a:t>On tooling: Polars loaded the source data 1.81x faster and ran aggregations 3.82x faster than Pandas. Standardizing the pipeline on Polars makes fast, frequent reconciliation checks cheap</a:t>
+              <a:t>On tooling: Polars loaded the source data 1.72x faster and ran aggregations 5.52x faster than Pandas. Standardizing the pipeline on Polars makes fast, frequent reconciliation checks cheap</a:t>
             </a:r>
           </a:p>
         </p:txBody>

</xml_diff>